<commit_message>
docs: update HSC presentation deck with AI disclosure and add 7-page PDF
</commit_message>
<xml_diff>
--- a/docs/CrowdShield_HSC_Presentation.pptx
+++ b/docs/CrowdShield_HSC_Presentation.pptx
@@ -3567,14 +3567,50 @@
       </p:sp>
       <p:sp>
         <p:nvSpPr>
-          <p:cNvPr id="12" name="Rounded Rectangle 11"/>
+          <p:cNvPr id="12" name="TextBox 11"/>
+          <p:cNvSpPr txBox="1"/>
+          <p:nvPr/>
+        </p:nvSpPr>
+        <p:spPr>
+          <a:xfrm>
+            <a:off x="731520" y="1051560"/>
+            <a:ext cx="10698480" cy="320040"/>
+          </a:xfrm>
+          <a:prstGeom prst="rect">
+            <a:avLst/>
+          </a:prstGeom>
+          <a:noFill/>
+        </p:spPr>
+        <p:txBody>
+          <a:bodyPr wrap="none">
+            <a:spAutoFit/>
+          </a:bodyPr>
+          <a:lstStyle/>
+          <a:p>
+            <a:pPr>
+              <a:defRPr sz="1100" b="1">
+                <a:solidFill>
+                  <a:srgbClr val="64748B"/>
+                </a:solidFill>
+                <a:latin typeface="Arial"/>
+              </a:defRPr>
+            </a:pPr>
+            <a:r>
+              <a:t>3-Tier System Architecture, Methodology &amp; End-to-End Operational Pipeline</a:t>
+            </a:r>
+          </a:p>
+        </p:txBody>
+      </p:sp>
+      <p:sp>
+        <p:nvSpPr>
+          <p:cNvPr id="13" name="Rounded Rectangle 12"/>
           <p:cNvSpPr/>
           <p:nvPr/>
         </p:nvSpPr>
         <p:spPr>
           <a:xfrm>
-            <a:off x="731520" y="1280160"/>
-            <a:ext cx="5120640" cy="3977639"/>
+            <a:off x="731520" y="1417320"/>
+            <a:ext cx="5120640" cy="3886200"/>
           </a:xfrm>
           <a:prstGeom prst="roundRect">
             <a:avLst/>
@@ -3733,7 +3769,7 @@
       </p:sp>
       <p:pic>
         <p:nvPicPr>
-          <p:cNvPr id="13" name="Picture 12" descr="architecture_diagram.png"/>
+          <p:cNvPr id="14" name="Picture 13" descr="architecture_diagram.png"/>
           <p:cNvPicPr>
             <a:picLocks noChangeAspect="1"/>
           </p:cNvPicPr>
@@ -3747,8 +3783,8 @@
         </p:blipFill>
         <p:spPr>
           <a:xfrm>
-            <a:off x="6035040" y="1280160"/>
-            <a:ext cx="5394960" cy="3977639"/>
+            <a:off x="6035040" y="1417320"/>
+            <a:ext cx="5394960" cy="3886200"/>
           </a:xfrm>
           <a:prstGeom prst="rect">
             <a:avLst/>
@@ -3757,7 +3793,7 @@
       </p:pic>
       <p:sp>
         <p:nvSpPr>
-          <p:cNvPr id="14" name="Rounded Rectangle 13"/>
+          <p:cNvPr id="15" name="Rounded Rectangle 14"/>
           <p:cNvSpPr/>
           <p:nvPr/>
         </p:nvSpPr>
@@ -4376,14 +4412,50 @@
       </p:sp>
       <p:sp>
         <p:nvSpPr>
-          <p:cNvPr id="12" name="Rounded Rectangle 11"/>
+          <p:cNvPr id="12" name="TextBox 11"/>
+          <p:cNvSpPr txBox="1"/>
+          <p:nvPr/>
+        </p:nvSpPr>
+        <p:spPr>
+          <a:xfrm>
+            <a:off x="731520" y="1051560"/>
+            <a:ext cx="10698480" cy="320040"/>
+          </a:xfrm>
+          <a:prstGeom prst="rect">
+            <a:avLst/>
+          </a:prstGeom>
+          <a:noFill/>
+        </p:spPr>
+        <p:txBody>
+          <a:bodyPr wrap="none">
+            <a:spAutoFit/>
+          </a:bodyPr>
+          <a:lstStyle/>
+          <a:p>
+            <a:pPr>
+              <a:defRPr sz="1100" b="1">
+                <a:solidFill>
+                  <a:srgbClr val="64748B"/>
+                </a:solidFill>
+                <a:latin typeface="Arial"/>
+              </a:defRPr>
+            </a:pPr>
+            <a:r>
+              <a:t>Target Audience Impact, Zero-Casualty Objective &amp; Stakeholder Scalability</a:t>
+            </a:r>
+          </a:p>
+        </p:txBody>
+      </p:sp>
+      <p:sp>
+        <p:nvSpPr>
+          <p:cNvPr id="13" name="Rounded Rectangle 12"/>
           <p:cNvSpPr/>
           <p:nvPr/>
         </p:nvSpPr>
         <p:spPr>
           <a:xfrm>
-            <a:off x="731520" y="1371600"/>
-            <a:ext cx="3383280" cy="4480560"/>
+            <a:off x="731520" y="1417320"/>
+            <a:ext cx="3383280" cy="4434840"/>
           </a:xfrm>
           <a:prstGeom prst="roundRect">
             <a:avLst/>
@@ -4518,14 +4590,14 @@
       </p:sp>
       <p:sp>
         <p:nvSpPr>
-          <p:cNvPr id="13" name="Rounded Rectangle 12"/>
+          <p:cNvPr id="14" name="Rounded Rectangle 13"/>
           <p:cNvSpPr/>
           <p:nvPr/>
         </p:nvSpPr>
         <p:spPr>
           <a:xfrm>
-            <a:off x="4389120" y="1371600"/>
-            <a:ext cx="3383280" cy="4480560"/>
+            <a:off x="4389120" y="1417320"/>
+            <a:ext cx="3383280" cy="4434840"/>
           </a:xfrm>
           <a:prstGeom prst="roundRect">
             <a:avLst/>
@@ -4660,14 +4732,14 @@
       </p:sp>
       <p:sp>
         <p:nvSpPr>
-          <p:cNvPr id="14" name="Rounded Rectangle 13"/>
+          <p:cNvPr id="15" name="Rounded Rectangle 14"/>
           <p:cNvSpPr/>
           <p:nvPr/>
         </p:nvSpPr>
         <p:spPr>
           <a:xfrm>
-            <a:off x="8046720" y="1371600"/>
-            <a:ext cx="3383280" cy="4480560"/>
+            <a:off x="8046720" y="1417320"/>
+            <a:ext cx="3383280" cy="4434840"/>
           </a:xfrm>
           <a:prstGeom prst="roundRect">
             <a:avLst/>
@@ -5350,14 +5422,50 @@
       </p:sp>
       <p:sp>
         <p:nvSpPr>
-          <p:cNvPr id="12" name="Rounded Rectangle 11"/>
+          <p:cNvPr id="12" name="TextBox 11"/>
+          <p:cNvSpPr txBox="1"/>
+          <p:nvPr/>
+        </p:nvSpPr>
+        <p:spPr>
+          <a:xfrm>
+            <a:off x="731520" y="1051560"/>
+            <a:ext cx="10698480" cy="320040"/>
+          </a:xfrm>
+          <a:prstGeom prst="rect">
+            <a:avLst/>
+          </a:prstGeom>
+          <a:noFill/>
+        </p:spPr>
+        <p:txBody>
+          <a:bodyPr wrap="none">
+            <a:spAutoFit/>
+          </a:bodyPr>
+          <a:lstStyle/>
+          <a:p>
+            <a:pPr>
+              <a:defRPr sz="1100" b="1">
+                <a:solidFill>
+                  <a:srgbClr val="64748B"/>
+                </a:solidFill>
+                <a:latin typeface="Arial"/>
+              </a:defRPr>
+            </a:pPr>
+            <a:r>
+              <a:t>Feasibility Analysis, Real-World Scalability &amp; Risk Mitigation Strategies</a:t>
+            </a:r>
+          </a:p>
+        </p:txBody>
+      </p:sp>
+      <p:sp>
+        <p:nvSpPr>
+          <p:cNvPr id="13" name="Rounded Rectangle 12"/>
           <p:cNvSpPr/>
           <p:nvPr/>
         </p:nvSpPr>
         <p:spPr>
           <a:xfrm>
-            <a:off x="731520" y="1371600"/>
-            <a:ext cx="5166360" cy="2011680"/>
+            <a:off x="731520" y="1417320"/>
+            <a:ext cx="5166360" cy="1965960"/>
           </a:xfrm>
           <a:prstGeom prst="roundRect">
             <a:avLst/>
@@ -5437,14 +5545,14 @@
       </p:sp>
       <p:sp>
         <p:nvSpPr>
-          <p:cNvPr id="13" name="Rounded Rectangle 12"/>
+          <p:cNvPr id="14" name="Rounded Rectangle 13"/>
           <p:cNvSpPr/>
           <p:nvPr/>
         </p:nvSpPr>
         <p:spPr>
           <a:xfrm>
-            <a:off x="6263640" y="1371600"/>
-            <a:ext cx="5166360" cy="2011680"/>
+            <a:off x="6263640" y="1417320"/>
+            <a:ext cx="5166360" cy="1965960"/>
           </a:xfrm>
           <a:prstGeom prst="roundRect">
             <a:avLst/>
@@ -5524,14 +5632,14 @@
       </p:sp>
       <p:sp>
         <p:nvSpPr>
-          <p:cNvPr id="14" name="Rounded Rectangle 13"/>
+          <p:cNvPr id="15" name="Rounded Rectangle 14"/>
           <p:cNvSpPr/>
           <p:nvPr/>
         </p:nvSpPr>
         <p:spPr>
           <a:xfrm>
             <a:off x="731520" y="3520440"/>
-            <a:ext cx="5166360" cy="2011680"/>
+            <a:ext cx="5166360" cy="1965960"/>
           </a:xfrm>
           <a:prstGeom prst="roundRect">
             <a:avLst/>
@@ -5611,14 +5719,14 @@
       </p:sp>
       <p:sp>
         <p:nvSpPr>
-          <p:cNvPr id="15" name="Rounded Rectangle 14"/>
+          <p:cNvPr id="16" name="Rounded Rectangle 15"/>
           <p:cNvSpPr/>
           <p:nvPr/>
         </p:nvSpPr>
         <p:spPr>
           <a:xfrm>
             <a:off x="6263640" y="3520440"/>
-            <a:ext cx="5166360" cy="2011680"/>
+            <a:ext cx="5166360" cy="1965960"/>
           </a:xfrm>
           <a:prstGeom prst="roundRect">
             <a:avLst/>
@@ -5698,7 +5806,7 @@
       </p:sp>
       <p:sp>
         <p:nvSpPr>
-          <p:cNvPr id="16" name="Rounded Rectangle 15"/>
+          <p:cNvPr id="17" name="Rounded Rectangle 16"/>
           <p:cNvSpPr/>
           <p:nvPr/>
         </p:nvSpPr>
@@ -6277,14 +6385,50 @@
       </p:sp>
       <p:sp>
         <p:nvSpPr>
-          <p:cNvPr id="12" name="Rounded Rectangle 11"/>
+          <p:cNvPr id="12" name="TextBox 11"/>
+          <p:cNvSpPr txBox="1"/>
+          <p:nvPr/>
+        </p:nvSpPr>
+        <p:spPr>
+          <a:xfrm>
+            <a:off x="731520" y="1051560"/>
+            <a:ext cx="10698480" cy="320040"/>
+          </a:xfrm>
+          <a:prstGeom prst="rect">
+            <a:avLst/>
+          </a:prstGeom>
+          <a:noFill/>
+        </p:spPr>
+        <p:txBody>
+          <a:bodyPr wrap="none">
+            <a:spAutoFit/>
+          </a:bodyPr>
+          <a:lstStyle/>
+          <a:p>
+            <a:pPr>
+              <a:defRPr sz="1100" b="1">
+                <a:solidFill>
+                  <a:srgbClr val="64748B"/>
+                </a:solidFill>
+                <a:latin typeface="Arial"/>
+              </a:defRPr>
+            </a:pPr>
+            <a:r>
+              <a:t>Team Composition, Member Roles &amp; Concrete Technical Implementation Breakdown</a:t>
+            </a:r>
+          </a:p>
+        </p:txBody>
+      </p:sp>
+      <p:sp>
+        <p:nvSpPr>
+          <p:cNvPr id="13" name="Rounded Rectangle 12"/>
           <p:cNvSpPr/>
           <p:nvPr/>
         </p:nvSpPr>
         <p:spPr>
           <a:xfrm>
-            <a:off x="731520" y="1371600"/>
-            <a:ext cx="5166360" cy="3017520"/>
+            <a:off x="731520" y="1417320"/>
+            <a:ext cx="5166360" cy="2971800"/>
           </a:xfrm>
           <a:prstGeom prst="roundRect">
             <a:avLst/>
@@ -6344,7 +6488,7 @@
           <a:p>
             <a:pPr>
               <a:spcBef>
-                <a:spcPts val="500"/>
+                <a:spcPts val="400"/>
               </a:spcBef>
               <a:defRPr sz="950" b="1">
                 <a:solidFill>
@@ -6354,15 +6498,15 @@
               </a:defRPr>
             </a:pPr>
             <a:r>
-              <a:t>• Key Responsibilities &amp; Contributions:</a:t>
-            </a:r>
-          </a:p>
-          <a:p>
-            <a:pPr>
-              <a:spcBef>
-                <a:spcPts val="300"/>
-              </a:spcBef>
-              <a:defRPr sz="900">
+              <a:t>• Technical Implementation Breakdown:</a:t>
+            </a:r>
+          </a:p>
+          <a:p>
+            <a:pPr>
+              <a:spcBef>
+                <a:spcPts val="200"/>
+              </a:spcBef>
+              <a:defRPr sz="880">
                 <a:solidFill>
                   <a:srgbClr val="334155"/>
                 </a:solidFill>
@@ -6370,7 +6514,7 @@
               </a:defRPr>
             </a:pPr>
             <a:r>
-              <a:t>- Designed embedded C++ firmware for ESP32 gateway and field nodes (SX1278 LoRa 433MHz, ESP-NOW, 1602 LCD, DFPlayer Mini).</a:t>
+              <a:t>- Designed embedded C++ firmware for ESP32 gateway &amp; field nodes (SX1278 LoRa 433MHz, ESP-NOW, 1602 LCD, DFPlayer Mini).</a:t>
             </a:r>
             <a:br/>
             <a:r>
@@ -6378,21 +6522,21 @@
             </a:r>
             <a:br/>
             <a:r>
-              <a:t>- Tuned LoRa 1MHz SPI clock &amp; RF power registers to eliminate brownouts and jumper wire noise.</a:t>
+              <a:t>- Tuned LoRa 1MHz SPI clock &amp; RF power registers to eliminate brownouts and bus line capacitance noise.</a:t>
             </a:r>
           </a:p>
         </p:txBody>
       </p:sp>
       <p:sp>
         <p:nvSpPr>
-          <p:cNvPr id="13" name="Rounded Rectangle 12"/>
+          <p:cNvPr id="14" name="Rounded Rectangle 13"/>
           <p:cNvSpPr/>
           <p:nvPr/>
         </p:nvSpPr>
         <p:spPr>
           <a:xfrm>
-            <a:off x="6263640" y="1371600"/>
-            <a:ext cx="5166360" cy="3017520"/>
+            <a:off x="6263640" y="1417320"/>
+            <a:ext cx="5166360" cy="2971800"/>
           </a:xfrm>
           <a:prstGeom prst="roundRect">
             <a:avLst/>
@@ -6452,7 +6596,7 @@
           <a:p>
             <a:pPr>
               <a:spcBef>
-                <a:spcPts val="500"/>
+                <a:spcPts val="400"/>
               </a:spcBef>
               <a:defRPr sz="950" b="1">
                 <a:solidFill>
@@ -6462,15 +6606,15 @@
               </a:defRPr>
             </a:pPr>
             <a:r>
-              <a:t>• Key Responsibilities &amp; Contributions:</a:t>
-            </a:r>
-          </a:p>
-          <a:p>
-            <a:pPr>
-              <a:spcBef>
-                <a:spcPts val="300"/>
-              </a:spcBef>
-              <a:defRPr sz="900">
+              <a:t>• Technical Implementation Breakdown:</a:t>
+            </a:r>
+          </a:p>
+          <a:p>
+            <a:pPr>
+              <a:spcBef>
+                <a:spcPts val="200"/>
+              </a:spcBef>
+              <a:defRPr sz="880">
                 <a:solidFill>
                   <a:srgbClr val="334155"/>
                 </a:solidFill>
@@ -6493,14 +6637,14 @@
       </p:sp>
       <p:sp>
         <p:nvSpPr>
-          <p:cNvPr id="14" name="Rounded Rectangle 13"/>
+          <p:cNvPr id="15" name="Rounded Rectangle 14"/>
           <p:cNvSpPr/>
           <p:nvPr/>
         </p:nvSpPr>
         <p:spPr>
           <a:xfrm>
             <a:off x="731520" y="4526280"/>
-            <a:ext cx="10698480" cy="1600200"/>
+            <a:ext cx="10698480" cy="1645920"/>
           </a:xfrm>
           <a:prstGeom prst="roundRect">
             <a:avLst/>
@@ -6533,7 +6677,7 @@
           <a:lstStyle/>
           <a:p>
             <a:pPr algn="ctr">
-              <a:defRPr sz="1050" b="1">
+              <a:defRPr sz="1000" b="1">
                 <a:solidFill>
                   <a:srgbClr val="1E3A8A"/>
                 </a:solidFill>
@@ -6541,7 +6685,7 @@
               </a:defRPr>
             </a:pPr>
             <a:r>
-              <a:t>OUR JOURNEY, CHALLENGES &amp; VISION:</a:t>
+              <a:t>OUR JOURNEY, CHALLENGES OVERCOME &amp; SYSTEM READINESS:</a:t>
             </a:r>
           </a:p>
           <a:p>
@@ -6549,7 +6693,7 @@
               <a:spcBef>
                 <a:spcPts val="300"/>
               </a:spcBef>
-              <a:defRPr sz="900">
+              <a:defRPr sz="880">
                 <a:solidFill>
                   <a:srgbClr val="0F172A"/>
                 </a:solidFill>
@@ -6565,7 +6709,7 @@
               <a:spcBef>
                 <a:spcPts val="200"/>
               </a:spcBef>
-              <a:defRPr sz="900">
+              <a:defRPr sz="880">
                 <a:solidFill>
                   <a:srgbClr val="0F172A"/>
                 </a:solidFill>
@@ -6581,7 +6725,7 @@
               <a:spcBef>
                 <a:spcPts val="200"/>
               </a:spcBef>
-              <a:defRPr sz="900" b="1">
+              <a:defRPr sz="880" b="1">
                 <a:solidFill>
                   <a:srgbClr val="059669"/>
                 </a:solidFill>
@@ -6589,7 +6733,7 @@
               </a:defRPr>
             </a:pPr>
             <a:r>
-              <a:t>• Team Vision: To turn tragedy into technical resilience. We built CrowdShield to ensure that no pilgrim, student, or festival-goer ever dies from an avoidable crowd crush in India.</a:t>
+              <a:t>• Team Vision &amp; Readiness: 100% implemented &amp; physically validated on ESP32 + LoRa + FastAPI + React testbench. Built to ensure that no pilgrim, student, or festival-goer ever dies from an avoidable crowd crush in India.</a:t>
             </a:r>
           </a:p>
         </p:txBody>
@@ -7120,14 +7264,213 @@
       </p:sp>
       <p:sp>
         <p:nvSpPr>
-          <p:cNvPr id="12" name="Rounded Rectangle 11"/>
+          <p:cNvPr id="12" name="TextBox 11"/>
+          <p:cNvSpPr txBox="1"/>
+          <p:nvPr/>
+        </p:nvSpPr>
+        <p:spPr>
+          <a:xfrm>
+            <a:off x="731520" y="1051560"/>
+            <a:ext cx="10698480" cy="320040"/>
+          </a:xfrm>
+          <a:prstGeom prst="rect">
+            <a:avLst/>
+          </a:prstGeom>
+          <a:noFill/>
+        </p:spPr>
+        <p:txBody>
+          <a:bodyPr wrap="none">
+            <a:spAutoFit/>
+          </a:bodyPr>
+          <a:lstStyle/>
+          <a:p>
+            <a:pPr>
+              <a:defRPr sz="1100" b="1">
+                <a:solidFill>
+                  <a:srgbClr val="64748B"/>
+                </a:solidFill>
+                <a:latin typeface="Arial"/>
+              </a:defRPr>
+            </a:pPr>
+            <a:r>
+              <a:t>Disclosure on the Extent of Usage of AI Tools &amp; Authoritative Academic / Technical References</a:t>
+            </a:r>
+          </a:p>
+        </p:txBody>
+      </p:sp>
+      <p:sp>
+        <p:nvSpPr>
+          <p:cNvPr id="13" name="Rounded Rectangle 12"/>
           <p:cNvSpPr/>
           <p:nvPr/>
         </p:nvSpPr>
         <p:spPr>
           <a:xfrm>
-            <a:off x="731520" y="1371600"/>
-            <a:ext cx="5166360" cy="4480560"/>
+            <a:off x="731520" y="1417320"/>
+            <a:ext cx="5166360" cy="4800600"/>
+          </a:xfrm>
+          <a:prstGeom prst="roundRect">
+            <a:avLst/>
+          </a:prstGeom>
+          <a:solidFill>
+            <a:srgbClr val="F8FAFC"/>
+          </a:solidFill>
+          <a:ln w="15240">
+            <a:solidFill>
+              <a:srgbClr val="0284C7"/>
+            </a:solidFill>
+          </a:ln>
+        </p:spPr>
+        <p:style>
+          <a:lnRef idx="1">
+            <a:schemeClr val="accent1"/>
+          </a:lnRef>
+          <a:fillRef idx="3">
+            <a:schemeClr val="accent1"/>
+          </a:fillRef>
+          <a:effectRef idx="2">
+            <a:schemeClr val="accent1"/>
+          </a:effectRef>
+          <a:fontRef idx="minor">
+            <a:schemeClr val="lt1"/>
+          </a:fontRef>
+        </p:style>
+        <p:txBody>
+          <a:bodyPr rtlCol="0" anchor="ctr" wrap="square" lIns="146304" tIns="146304" rIns="146304" bIns="146304"/>
+          <a:lstStyle/>
+          <a:p>
+            <a:pPr algn="ctr">
+              <a:defRPr sz="1100" b="1">
+                <a:solidFill>
+                  <a:srgbClr val="1E3A8A"/>
+                </a:solidFill>
+                <a:latin typeface="Arial"/>
+              </a:defRPr>
+            </a:pPr>
+            <a:r>
+              <a:t>DISCLOSURE ON EXTENT OF USAGE OF AI TOOLS</a:t>
+            </a:r>
+          </a:p>
+          <a:p>
+            <a:pPr>
+              <a:spcBef>
+                <a:spcPts val="500"/>
+              </a:spcBef>
+              <a:defRPr sz="950" b="1">
+                <a:solidFill>
+                  <a:srgbClr val="0F172A"/>
+                </a:solidFill>
+                <a:latin typeface="Arial"/>
+              </a:defRPr>
+            </a:pPr>
+            <a:r>
+              <a:t>1. Edge Computer Vision AI Models (Implemented):</a:t>
+            </a:r>
+          </a:p>
+          <a:p>
+            <a:pPr>
+              <a:spcBef>
+                <a:spcPts val="200"/>
+              </a:spcBef>
+              <a:defRPr sz="850">
+                <a:solidFill>
+                  <a:srgbClr val="334155"/>
+                </a:solidFill>
+                <a:latin typeface="Arial"/>
+              </a:defRPr>
+            </a:pPr>
+            <a:r>
+              <a:t>• YOLOv8 Head Detection: Localized object detection trained on SCUT-HEAD &amp; ShanghaiTech crowd datasets for crowd head counting.</a:t>
+            </a:r>
+            <a:br/>
+            <a:r>
+              <a:t>• 4-Point Homography Transform: Calibrated 3x3 perspective matrix H mapping camera pixels to true metric pax/m².</a:t>
+            </a:r>
+            <a:br/>
+            <a:r>
+              <a:t>• Farnebäck Optical Flow: Dense vector variance computing Directional Conflict Index (&gt;0.65) and vertical drop fall signatures in real-time.</a:t>
+            </a:r>
+          </a:p>
+          <a:p>
+            <a:pPr>
+              <a:spcBef>
+                <a:spcPts val="500"/>
+              </a:spcBef>
+              <a:defRPr sz="950" b="1">
+                <a:solidFill>
+                  <a:srgbClr val="0F172A"/>
+                </a:solidFill>
+                <a:latin typeface="Arial"/>
+              </a:defRPr>
+            </a:pPr>
+            <a:r>
+              <a:t>2. Generative AI / LLM Assistance Disclosure (HSC Compliance):</a:t>
+            </a:r>
+          </a:p>
+          <a:p>
+            <a:pPr>
+              <a:spcBef>
+                <a:spcPts val="200"/>
+              </a:spcBef>
+              <a:defRPr sz="850">
+                <a:solidFill>
+                  <a:srgbClr val="334155"/>
+                </a:solidFill>
+                <a:latin typeface="Arial"/>
+              </a:defRPr>
+            </a:pPr>
+            <a:r>
+              <a:t>• Code Scaffolding &amp; Syntax Optimization: Generative AI tools (LLMs) were utilized for code scaffolding, boilerplate optimization, documentation synthesis, and presentation formatting per HSC 2027 guidelines.</a:t>
+            </a:r>
+            <a:br/>
+            <a:r>
+              <a:t>• Human-Authored Core Logic: All system architectures, firmware C++ routines, LoRa SPI clock register configurations, and mathematical formulas were human-authored, verified, and debugged on physical hardware.</a:t>
+            </a:r>
+          </a:p>
+          <a:p>
+            <a:pPr>
+              <a:spcBef>
+                <a:spcPts val="500"/>
+              </a:spcBef>
+              <a:defRPr sz="950" b="1">
+                <a:solidFill>
+                  <a:srgbClr val="0F172A"/>
+                </a:solidFill>
+                <a:latin typeface="Arial"/>
+              </a:defRPr>
+            </a:pPr>
+            <a:r>
+              <a:t>3. Strict Deterministic Safety Boundary (Zero Hallucination):</a:t>
+            </a:r>
+          </a:p>
+          <a:p>
+            <a:pPr>
+              <a:spcBef>
+                <a:spcPts val="200"/>
+              </a:spcBef>
+              <a:defRPr sz="850">
+                <a:solidFill>
+                  <a:srgbClr val="059669"/>
+                </a:solidFill>
+                <a:latin typeface="Arial"/>
+              </a:defRPr>
+            </a:pPr>
+            <a:r>
+              <a:t>• Zero Generative Decision-Making: Emergency life-safety rerouting and incident isolation are strictly executed by deterministic graph mathematics (NetworkX Dijkstra), ensuring 100% predictable life-safety compliance.</a:t>
+            </a:r>
+          </a:p>
+        </p:txBody>
+      </p:sp>
+      <p:sp>
+        <p:nvSpPr>
+          <p:cNvPr id="14" name="Rounded Rectangle 13"/>
+          <p:cNvSpPr/>
+          <p:nvPr/>
+        </p:nvSpPr>
+        <p:spPr>
+          <a:xfrm>
+            <a:off x="6263640" y="1417320"/>
+            <a:ext cx="5166360" cy="4800600"/>
           </a:xfrm>
           <a:prstGeom prst="roundRect">
             <a:avLst/>
@@ -7156,7 +7499,7 @@
           </a:fontRef>
         </p:style>
         <p:txBody>
-          <a:bodyPr rtlCol="0" anchor="ctr" wrap="square" lIns="164592" tIns="164592" rIns="164592" bIns="164592"/>
+          <a:bodyPr rtlCol="0" anchor="ctr" wrap="square" lIns="146304" tIns="146304" rIns="146304" bIns="146304"/>
           <a:lstStyle/>
           <a:p>
             <a:pPr algn="ctr">
@@ -7168,15 +7511,15 @@
               </a:defRPr>
             </a:pPr>
             <a:r>
-              <a:t>CROWD DYNAMICS &amp; DISASTER MITIGATION</a:t>
-            </a:r>
-          </a:p>
-          <a:p>
-            <a:pPr>
-              <a:spcBef>
-                <a:spcPts val="600"/>
-              </a:spcBef>
-              <a:defRPr sz="950" b="1">
+              <a:t>AUTHORITATIVE RESEARCH &amp; TECHNICAL REFERENCES</a:t>
+            </a:r>
+          </a:p>
+          <a:p>
+            <a:pPr>
+              <a:spcBef>
+                <a:spcPts val="400"/>
+              </a:spcBef>
+              <a:defRPr sz="900" b="1">
                 <a:solidFill>
                   <a:srgbClr val="0F172A"/>
                 </a:solidFill>
@@ -7189,20 +7532,62 @@
           </a:p>
           <a:p>
             <a:pPr>
+              <a:defRPr sz="850" b="1">
+                <a:solidFill>
+                  <a:srgbClr val="0284C7"/>
+                </a:solidFill>
+                <a:latin typeface="Arial"/>
+              </a:defRPr>
+            </a:pPr>
+            <a:r>
+              <a:t>  "Pedestrian Planning and Design"</a:t>
+            </a:r>
+          </a:p>
+          <a:p>
+            <a:pPr>
+              <a:defRPr sz="800">
+                <a:solidFill>
+                  <a:srgbClr val="334155"/>
+                </a:solidFill>
+                <a:latin typeface="Arial"/>
+              </a:defRPr>
+            </a:pPr>
+            <a:r>
+              <a:t>  Metropolitan Association of Urban Designers and Environmental Planners, New York. Level of Service (LoS A-F) benchmark standards for human crowd flow and bottleneck capacity.</a:t>
+            </a:r>
+          </a:p>
+          <a:p>
+            <a:pPr>
+              <a:spcBef>
+                <a:spcPts val="400"/>
+              </a:spcBef>
               <a:defRPr sz="900" b="1">
                 <a:solidFill>
+                  <a:srgbClr val="0F172A"/>
+                </a:solidFill>
+                <a:latin typeface="Arial"/>
+              </a:defRPr>
+            </a:pPr>
+            <a:r>
+              <a:t>• Helbing, D., Farkas, I., &amp; Vicsek, T. (2000):</a:t>
+            </a:r>
+          </a:p>
+          <a:p>
+            <a:pPr>
+              <a:defRPr sz="850" b="1">
+                <a:solidFill>
                   <a:srgbClr val="0284C7"/>
                 </a:solidFill>
                 <a:latin typeface="Arial"/>
               </a:defRPr>
             </a:pPr>
             <a:r>
-              <a:t>  "Pedestrian Planning and Design"</a:t>
-            </a:r>
-          </a:p>
-          <a:p>
-            <a:pPr>
-              <a:defRPr sz="850">
+              <a:t>  "Simulating dynamical features of escape panic"</a:t>
+            </a:r>
+          </a:p>
+          <a:p>
+            <a:pPr>
+              <a:defRPr sz="800">
                 <a:solidFill>
                   <a:srgbClr val="334155"/>
                 </a:solidFill>
@@ -7210,15 +7595,15 @@
               </a:defRPr>
             </a:pPr>
             <a:r>
-              <a:t>  Metropolitan Association of Urban Designers and Environmental Planners, New York. Defined Level of Service (LoS A-F) benchmark standards for human crowd flow and bottleneck capacities.</a:t>
-            </a:r>
-          </a:p>
-          <a:p>
-            <a:pPr>
-              <a:spcBef>
-                <a:spcPts val="600"/>
-              </a:spcBef>
-              <a:defRPr sz="950" b="1">
+              <a:t>  Nature, 407(6803), 487-490. Mathematical modeling of physical crowd 'freezing-by-heating' and crushing shockwaves.</a:t>
+            </a:r>
+          </a:p>
+          <a:p>
+            <a:pPr>
+              <a:spcBef>
+                <a:spcPts val="400"/>
+              </a:spcBef>
+              <a:defRPr sz="900" b="1">
                 <a:solidFill>
                   <a:srgbClr val="0F172A"/>
                 </a:solidFill>
@@ -7226,25 +7611,67 @@
               </a:defRPr>
             </a:pPr>
             <a:r>
-              <a:t>• Helbing, D., Farkas, I., &amp; Vicsek, T. (2000):</a:t>
-            </a:r>
-          </a:p>
-          <a:p>
-            <a:pPr>
+              <a:t>• National Disaster Management Authority (NDMA), Govt. of India (2014):</a:t>
+            </a:r>
+          </a:p>
+          <a:p>
+            <a:pPr>
+              <a:defRPr sz="850" b="1">
+                <a:solidFill>
+                  <a:srgbClr val="0284C7"/>
+                </a:solidFill>
+                <a:latin typeface="Arial"/>
+              </a:defRPr>
+            </a:pPr>
+            <a:r>
+              <a:t>  "Managing Crowd at Events and Venues of Mass Gathering: A Guide"</a:t>
+            </a:r>
+          </a:p>
+          <a:p>
+            <a:pPr>
+              <a:defRPr sz="800">
+                <a:solidFill>
+                  <a:srgbClr val="334155"/>
+                </a:solidFill>
+                <a:latin typeface="Arial"/>
+              </a:defRPr>
+            </a:pPr>
+            <a:r>
+              <a:t>  New Delhi: NDMA. National standards for ingress/egress ratios and stampede prevention protocols.</a:t>
+            </a:r>
+          </a:p>
+          <a:p>
+            <a:pPr>
+              <a:spcBef>
+                <a:spcPts val="400"/>
+              </a:spcBef>
               <a:defRPr sz="900" b="1">
                 <a:solidFill>
+                  <a:srgbClr val="0F172A"/>
+                </a:solidFill>
+                <a:latin typeface="Arial"/>
+              </a:defRPr>
+            </a:pPr>
+            <a:r>
+              <a:t>• Li, Y., Zhang, X., &amp; Chen, D. (2018):</a:t>
+            </a:r>
+          </a:p>
+          <a:p>
+            <a:pPr>
+              <a:defRPr sz="850" b="1">
+                <a:solidFill>
                   <a:srgbClr val="0284C7"/>
                 </a:solidFill>
                 <a:latin typeface="Arial"/>
               </a:defRPr>
             </a:pPr>
             <a:r>
-              <a:t>  "Simulating dynamical features of escape panic"</a:t>
-            </a:r>
-          </a:p>
-          <a:p>
-            <a:pPr>
-              <a:defRPr sz="850">
+              <a:t>  "CSRNet: Dilated Convolutional Neural Networks for Congested Scenes"</a:t>
+            </a:r>
+          </a:p>
+          <a:p>
+            <a:pPr>
+              <a:defRPr sz="800">
                 <a:solidFill>
                   <a:srgbClr val="334155"/>
                 </a:solidFill>
@@ -7252,15 +7679,15 @@
               </a:defRPr>
             </a:pPr>
             <a:r>
-              <a:t>  Nature, 407(6803), 487-490. Mathematical modeling of physical crowd 'freezing-by-heating' and crushing shockwaves.</a:t>
-            </a:r>
-          </a:p>
-          <a:p>
-            <a:pPr>
-              <a:spcBef>
-                <a:spcPts val="600"/>
-              </a:spcBef>
-              <a:defRPr sz="950" b="1">
+              <a:t>  IEEE/CVF CVPR, pp. 1091-1100. ShanghaiTech crowd counting benchmark.</a:t>
+            </a:r>
+          </a:p>
+          <a:p>
+            <a:pPr>
+              <a:spcBef>
+                <a:spcPts val="400"/>
+              </a:spcBef>
+              <a:defRPr sz="900" b="1">
                 <a:solidFill>
                   <a:srgbClr val="0F172A"/>
                 </a:solidFill>
@@ -7268,25 +7695,67 @@
               </a:defRPr>
             </a:pPr>
             <a:r>
-              <a:t>• National Disaster Management Authority (NDMA), Govt. of India (2014):</a:t>
-            </a:r>
-          </a:p>
-          <a:p>
-            <a:pPr>
+              <a:t>• Farnebäck, G. (2003):</a:t>
+            </a:r>
+          </a:p>
+          <a:p>
+            <a:pPr>
+              <a:defRPr sz="850" b="1">
+                <a:solidFill>
+                  <a:srgbClr val="0284C7"/>
+                </a:solidFill>
+                <a:latin typeface="Arial"/>
+              </a:defRPr>
+            </a:pPr>
+            <a:r>
+              <a:t>  "Two-Frame Motion Estimation Based on Polynomial Expansion"</a:t>
+            </a:r>
+          </a:p>
+          <a:p>
+            <a:pPr>
+              <a:defRPr sz="800">
+                <a:solidFill>
+                  <a:srgbClr val="334155"/>
+                </a:solidFill>
+                <a:latin typeface="Arial"/>
+              </a:defRPr>
+            </a:pPr>
+            <a:r>
+              <a:t>  SCIA, Springer LNCS 2749, pp. 363-370. Dense optical flow vector field calculation.</a:t>
+            </a:r>
+          </a:p>
+          <a:p>
+            <a:pPr>
+              <a:spcBef>
+                <a:spcPts val="400"/>
+              </a:spcBef>
               <a:defRPr sz="900" b="1">
                 <a:solidFill>
+                  <a:srgbClr val="0F172A"/>
+                </a:solidFill>
+                <a:latin typeface="Arial"/>
+              </a:defRPr>
+            </a:pPr>
+            <a:r>
+              <a:t>• Semtech Corp. (2020) &amp; Espressif Systems (2024):</a:t>
+            </a:r>
+          </a:p>
+          <a:p>
+            <a:pPr>
+              <a:defRPr sz="850" b="1">
+                <a:solidFill>
                   <a:srgbClr val="0284C7"/>
                 </a:solidFill>
                 <a:latin typeface="Arial"/>
               </a:defRPr>
             </a:pPr>
             <a:r>
-              <a:t>  "Managing Crowd at Events and Venues of Mass Gathering: A Guide for Administrators and Organizers"</a:t>
-            </a:r>
-          </a:p>
-          <a:p>
-            <a:pPr>
-              <a:defRPr sz="850">
+              <a:t>  "SX1278 LoRa &amp; ESP-NOW Specifications"</a:t>
+            </a:r>
+          </a:p>
+          <a:p>
+            <a:pPr>
+              <a:defRPr sz="800">
                 <a:solidFill>
                   <a:srgbClr val="334155"/>
                 </a:solidFill>
@@ -7294,272 +7763,7 @@
               </a:defRPr>
             </a:pPr>
             <a:r>
-              <a:t>  New Delhi: NDMA. National standards for ingress/egress ratios and stampede prevention protocols.</a:t>
-            </a:r>
-          </a:p>
-          <a:p>
-            <a:pPr>
-              <a:spcBef>
-                <a:spcPts val="600"/>
-              </a:spcBef>
-              <a:defRPr sz="950" b="1">
-                <a:solidFill>
-                  <a:srgbClr val="0F172A"/>
-                </a:solidFill>
-                <a:latin typeface="Arial"/>
-              </a:defRPr>
-            </a:pPr>
-            <a:r>
-              <a:t>• Still, G. K. (2014):</a:t>
-            </a:r>
-          </a:p>
-          <a:p>
-            <a:pPr>
-              <a:defRPr sz="900" b="1">
-                <a:solidFill>
-                  <a:srgbClr val="0284C7"/>
-                </a:solidFill>
-                <a:latin typeface="Arial"/>
-              </a:defRPr>
-            </a:pPr>
-            <a:r>
-              <a:t>  "Introduction to Crowd Science"</a:t>
-            </a:r>
-          </a:p>
-          <a:p>
-            <a:pPr>
-              <a:defRPr sz="850">
-                <a:solidFill>
-                  <a:srgbClr val="334155"/>
-                </a:solidFill>
-                <a:latin typeface="Arial"/>
-              </a:defRPr>
-            </a:pPr>
-            <a:r>
-              <a:t>  CRC Press, Taylor &amp; Francis Group. Principles of crowd density risk modeling and bottleneck prevention.</a:t>
-            </a:r>
-          </a:p>
-        </p:txBody>
-      </p:sp>
-      <p:sp>
-        <p:nvSpPr>
-          <p:cNvPr id="13" name="Rounded Rectangle 12"/>
-          <p:cNvSpPr/>
-          <p:nvPr/>
-        </p:nvSpPr>
-        <p:spPr>
-          <a:xfrm>
-            <a:off x="6263640" y="1371600"/>
-            <a:ext cx="5166360" cy="4480560"/>
-          </a:xfrm>
-          <a:prstGeom prst="roundRect">
-            <a:avLst/>
-          </a:prstGeom>
-          <a:solidFill>
-            <a:srgbClr val="F8FAFC"/>
-          </a:solidFill>
-          <a:ln w="15240">
-            <a:solidFill>
-              <a:srgbClr val="E2E8F0"/>
-            </a:solidFill>
-          </a:ln>
-        </p:spPr>
-        <p:style>
-          <a:lnRef idx="1">
-            <a:schemeClr val="accent1"/>
-          </a:lnRef>
-          <a:fillRef idx="3">
-            <a:schemeClr val="accent1"/>
-          </a:fillRef>
-          <a:effectRef idx="2">
-            <a:schemeClr val="accent1"/>
-          </a:effectRef>
-          <a:fontRef idx="minor">
-            <a:schemeClr val="lt1"/>
-          </a:fontRef>
-        </p:style>
-        <p:txBody>
-          <a:bodyPr rtlCol="0" anchor="ctr" wrap="square" lIns="164592" tIns="164592" rIns="164592" bIns="164592"/>
-          <a:lstStyle/>
-          <a:p>
-            <a:pPr algn="ctr">
-              <a:defRPr sz="1100" b="1">
-                <a:solidFill>
-                  <a:srgbClr val="1E3A8A"/>
-                </a:solidFill>
-                <a:latin typeface="Arial"/>
-              </a:defRPr>
-            </a:pPr>
-            <a:r>
-              <a:t>COMPUTER VISION &amp; EMBEDDED PROTOCOLS</a:t>
-            </a:r>
-          </a:p>
-          <a:p>
-            <a:pPr>
-              <a:spcBef>
-                <a:spcPts val="600"/>
-              </a:spcBef>
-              <a:defRPr sz="950" b="1">
-                <a:solidFill>
-                  <a:srgbClr val="0F172A"/>
-                </a:solidFill>
-                <a:latin typeface="Arial"/>
-              </a:defRPr>
-            </a:pPr>
-            <a:r>
-              <a:t>• Li, Y., Zhang, X., &amp; Chen, D. (2018):</a:t>
-            </a:r>
-          </a:p>
-          <a:p>
-            <a:pPr>
-              <a:defRPr sz="900" b="1">
-                <a:solidFill>
-                  <a:srgbClr val="0284C7"/>
-                </a:solidFill>
-                <a:latin typeface="Arial"/>
-              </a:defRPr>
-            </a:pPr>
-            <a:r>
-              <a:t>  "CSRNet: Dilated Convolutional Neural Networks for Understanding Highly Congested Scenes"</a:t>
-            </a:r>
-          </a:p>
-          <a:p>
-            <a:pPr>
-              <a:defRPr sz="850">
-                <a:solidFill>
-                  <a:srgbClr val="334155"/>
-                </a:solidFill>
-                <a:latin typeface="Arial"/>
-              </a:defRPr>
-            </a:pPr>
-            <a:r>
-              <a:t>  IEEE/CVF Conference on Computer Vision and Pattern Recognition (CVPR), pp. 1091-1100. ShanghaiTech crowd counting benchmark.</a:t>
-            </a:r>
-          </a:p>
-          <a:p>
-            <a:pPr>
-              <a:spcBef>
-                <a:spcPts val="600"/>
-              </a:spcBef>
-              <a:defRPr sz="950" b="1">
-                <a:solidFill>
-                  <a:srgbClr val="0F172A"/>
-                </a:solidFill>
-                <a:latin typeface="Arial"/>
-              </a:defRPr>
-            </a:pPr>
-            <a:r>
-              <a:t>• Farnebäck, G. (2003):</a:t>
-            </a:r>
-          </a:p>
-          <a:p>
-            <a:pPr>
-              <a:defRPr sz="900" b="1">
-                <a:solidFill>
-                  <a:srgbClr val="0284C7"/>
-                </a:solidFill>
-                <a:latin typeface="Arial"/>
-              </a:defRPr>
-            </a:pPr>
-            <a:r>
-              <a:t>  "Two-Frame Motion Estimation Based on Polynomial Expansion"</a:t>
-            </a:r>
-          </a:p>
-          <a:p>
-            <a:pPr>
-              <a:defRPr sz="850">
-                <a:solidFill>
-                  <a:srgbClr val="334155"/>
-                </a:solidFill>
-                <a:latin typeface="Arial"/>
-              </a:defRPr>
-            </a:pPr>
-            <a:r>
-              <a:t>  Scandinavian Conference on Image Analysis (SCIA), Springer LNCS 2749, pp. 363-370. Dense optical flow vector field calculation.</a:t>
-            </a:r>
-          </a:p>
-          <a:p>
-            <a:pPr>
-              <a:spcBef>
-                <a:spcPts val="600"/>
-              </a:spcBef>
-              <a:defRPr sz="950" b="1">
-                <a:solidFill>
-                  <a:srgbClr val="0F172A"/>
-                </a:solidFill>
-                <a:latin typeface="Arial"/>
-              </a:defRPr>
-            </a:pPr>
-            <a:r>
-              <a:t>• Semtech Corporation (2020):</a:t>
-            </a:r>
-          </a:p>
-          <a:p>
-            <a:pPr>
-              <a:defRPr sz="900" b="1">
-                <a:solidFill>
-                  <a:srgbClr val="0284C7"/>
-                </a:solidFill>
-                <a:latin typeface="Arial"/>
-              </a:defRPr>
-            </a:pPr>
-            <a:r>
-              <a:t>  "SX1276/77/78/79 Ultra-Low Power Long Range Transceiver Datasheet"</a:t>
-            </a:r>
-          </a:p>
-          <a:p>
-            <a:pPr>
-              <a:defRPr sz="850">
-                <a:solidFill>
-                  <a:srgbClr val="334155"/>
-                </a:solidFill>
-                <a:latin typeface="Arial"/>
-              </a:defRPr>
-            </a:pPr>
-            <a:r>
-              <a:t>  Semtech Wireless &amp; Sensing Products, Rev. 7. Specifications for 433MHz SF9 bandwidth and link budget.</a:t>
-            </a:r>
-          </a:p>
-          <a:p>
-            <a:pPr>
-              <a:spcBef>
-                <a:spcPts val="600"/>
-              </a:spcBef>
-              <a:defRPr sz="950" b="1">
-                <a:solidFill>
-                  <a:srgbClr val="0F172A"/>
-                </a:solidFill>
-                <a:latin typeface="Arial"/>
-              </a:defRPr>
-            </a:pPr>
-            <a:r>
-              <a:t>• Espressif Systems (2024):</a:t>
-            </a:r>
-          </a:p>
-          <a:p>
-            <a:pPr>
-              <a:defRPr sz="900" b="1">
-                <a:solidFill>
-                  <a:srgbClr val="0284C7"/>
-                </a:solidFill>
-                <a:latin typeface="Arial"/>
-              </a:defRPr>
-            </a:pPr>
-            <a:r>
-              <a:t>  "ESP-NOW Technical Reference &amp; Peer-to-Peer Protocol Specification"</a:t>
-            </a:r>
-          </a:p>
-          <a:p>
-            <a:pPr>
-              <a:defRPr sz="850">
-                <a:solidFill>
-                  <a:srgbClr val="334155"/>
-                </a:solidFill>
-                <a:latin typeface="Arial"/>
-              </a:defRPr>
-            </a:pPr>
-            <a:r>
-              <a:t>  Espressif Systems, Shanghai. Low-latency, connectionless peer-to-peer Wi-Fi packet frame communication standards.</a:t>
+              <a:t>  Semtech SX1278 Rev. 7 &amp; Espressif ESP-NOW Protocol. 433MHz SF9 RF bandwidth and peer-to-peer packet standards.</a:t>
             </a:r>
           </a:p>
         </p:txBody>

</xml_diff>